<commit_message>
Figure 3: re-export user's manually-edited figure3.pptx into the paper
Re-exported the user-updated figure3.pptx -> figure3.pdf (951x190, same footprint),
installed and recompiled: 5 pages, 0 undefined, body still 4pp (§5 on page 4).
</commit_message>
<xml_diff>
--- a/outputs/paper/figure3.pptx
+++ b/outputs/paper/figure3.pptx
@@ -36,7 +36,7 @@
             <a:spLocks noGrp="1"/>
           </p:cNvSpPr>
           <p:nvPr>
-            <p:ph type="ftr" idx="2"/>
+            <p:ph type="ftr" idx="1"/>
           </p:nvPr>
         </p:nvSpPr>
         <p:spPr/>
@@ -56,14 +56,14 @@
             <a:spLocks noGrp="1"/>
           </p:cNvSpPr>
           <p:nvPr>
-            <p:ph type="sldNum" idx="3"/>
+            <p:ph type="sldNum" idx="2"/>
           </p:nvPr>
         </p:nvSpPr>
         <p:spPr/>
         <p:txBody>
           <a:bodyPr/>
           <a:p>
-            <a:fld id="{B5E1221D-2675-4D88-95AC-BCB57AAEC0BD}" type="slidenum">
+            <a:fld id="{73129D64-FFED-430F-9DE3-9550FCC23468}" type="slidenum">
               <a:t>&lt;#&gt;</a:t>
             </a:fld>
           </a:p>
@@ -76,7 +76,7 @@
             <a:spLocks noGrp="1"/>
           </p:cNvSpPr>
           <p:nvPr>
-            <p:ph type="dt" idx="1"/>
+            <p:ph type="dt" idx="3"/>
           </p:nvPr>
         </p:nvSpPr>
         <p:spPr/>
@@ -124,8 +124,8 @@
         </p:nvSpPr>
         <p:spPr>
           <a:xfrm>
-            <a:off x="609120" y="103680"/>
-            <a:ext cx="10969560" cy="434520"/>
+            <a:off x="609120" y="8640"/>
+            <a:ext cx="10969560" cy="625320"/>
           </a:xfrm>
           <a:prstGeom prst="rect">
             <a:avLst/>
@@ -140,11 +140,11 @@
             <a:noAutofit/>
           </a:bodyPr>
           <a:p>
-            <a:endParaRPr b="0" lang="en-US" sz="1800" spc="-1" strike="noStrike">
-              <a:solidFill>
-                <a:srgbClr val="000000"/>
-              </a:solidFill>
-              <a:latin typeface="Calibri"/>
+            <a:pPr algn="ctr">
+              <a:buNone/>
+            </a:pPr>
+            <a:endParaRPr b="0" lang="en-US" sz="4400" spc="-1" strike="noStrike">
+              <a:latin typeface="Arial"/>
             </a:endParaRPr>
           </a:p>
         </p:txBody>
@@ -161,8 +161,8 @@
         </p:nvSpPr>
         <p:spPr>
           <a:xfrm>
-            <a:off x="609120" y="609480"/>
-            <a:ext cx="10969560" cy="720360"/>
+            <a:off x="609120" y="609840"/>
+            <a:ext cx="10969560" cy="720720"/>
           </a:xfrm>
           <a:prstGeom prst="rect">
             <a:avLst/>
@@ -178,10 +178,7 @@
           </a:bodyPr>
           <a:p>
             <a:endParaRPr b="0" lang="en-US" sz="3200" spc="-1" strike="noStrike">
-              <a:solidFill>
-                <a:srgbClr val="000000"/>
-              </a:solidFill>
-              <a:latin typeface="Calibri"/>
+              <a:latin typeface="Arial"/>
             </a:endParaRPr>
           </a:p>
         </p:txBody>
@@ -198,8 +195,8 @@
         </p:nvSpPr>
         <p:spPr>
           <a:xfrm>
-            <a:off x="609120" y="1398600"/>
-            <a:ext cx="10969560" cy="720360"/>
+            <a:off x="609120" y="1399320"/>
+            <a:ext cx="10969560" cy="720720"/>
           </a:xfrm>
           <a:prstGeom prst="rect">
             <a:avLst/>
@@ -215,10 +212,7 @@
           </a:bodyPr>
           <a:p>
             <a:endParaRPr b="0" lang="en-US" sz="3200" spc="-1" strike="noStrike">
-              <a:solidFill>
-                <a:srgbClr val="000000"/>
-              </a:solidFill>
-              <a:latin typeface="Calibri"/>
+              <a:latin typeface="Arial"/>
             </a:endParaRPr>
           </a:p>
         </p:txBody>
@@ -230,7 +224,7 @@
             <a:spLocks noGrp="1"/>
           </p:cNvSpPr>
           <p:nvPr>
-            <p:ph type="ftr" idx="2"/>
+            <p:ph type="ftr" idx="1"/>
           </p:nvPr>
         </p:nvSpPr>
         <p:spPr/>
@@ -250,14 +244,14 @@
             <a:spLocks noGrp="1"/>
           </p:cNvSpPr>
           <p:nvPr>
-            <p:ph type="sldNum" idx="3"/>
+            <p:ph type="sldNum" idx="2"/>
           </p:nvPr>
         </p:nvSpPr>
         <p:spPr/>
         <p:txBody>
           <a:bodyPr/>
           <a:p>
-            <a:fld id="{2E9FBE96-8D4F-4E1C-9EAC-5CCF0BE63F65}" type="slidenum">
+            <a:fld id="{9D77478E-CC05-48EE-B8AD-AD92E949E358}" type="slidenum">
               <a:t>&lt;#&gt;</a:t>
             </a:fld>
           </a:p>
@@ -270,7 +264,7 @@
             <a:spLocks noGrp="1"/>
           </p:cNvSpPr>
           <p:nvPr>
-            <p:ph type="dt" idx="1"/>
+            <p:ph type="dt" idx="3"/>
           </p:nvPr>
         </p:nvSpPr>
         <p:spPr/>
@@ -318,8 +312,8 @@
         </p:nvSpPr>
         <p:spPr>
           <a:xfrm>
-            <a:off x="609120" y="103680"/>
-            <a:ext cx="10969560" cy="434520"/>
+            <a:off x="609120" y="8640"/>
+            <a:ext cx="10969560" cy="625320"/>
           </a:xfrm>
           <a:prstGeom prst="rect">
             <a:avLst/>
@@ -334,11 +328,11 @@
             <a:noAutofit/>
           </a:bodyPr>
           <a:p>
-            <a:endParaRPr b="0" lang="en-US" sz="1800" spc="-1" strike="noStrike">
-              <a:solidFill>
-                <a:srgbClr val="000000"/>
-              </a:solidFill>
-              <a:latin typeface="Calibri"/>
+            <a:pPr algn="ctr">
+              <a:buNone/>
+            </a:pPr>
+            <a:endParaRPr b="0" lang="en-US" sz="4400" spc="-1" strike="noStrike">
+              <a:latin typeface="Arial"/>
             </a:endParaRPr>
           </a:p>
         </p:txBody>
@@ -355,8 +349,8 @@
         </p:nvSpPr>
         <p:spPr>
           <a:xfrm>
-            <a:off x="609120" y="609480"/>
-            <a:ext cx="5352840" cy="720360"/>
+            <a:off x="609120" y="609840"/>
+            <a:ext cx="5352840" cy="720720"/>
           </a:xfrm>
           <a:prstGeom prst="rect">
             <a:avLst/>
@@ -372,10 +366,7 @@
           </a:bodyPr>
           <a:p>
             <a:endParaRPr b="0" lang="en-US" sz="3200" spc="-1" strike="noStrike">
-              <a:solidFill>
-                <a:srgbClr val="000000"/>
-              </a:solidFill>
-              <a:latin typeface="Calibri"/>
+              <a:latin typeface="Arial"/>
             </a:endParaRPr>
           </a:p>
         </p:txBody>
@@ -392,8 +383,8 @@
         </p:nvSpPr>
         <p:spPr>
           <a:xfrm>
-            <a:off x="6230160" y="609480"/>
-            <a:ext cx="5352840" cy="720360"/>
+            <a:off x="6230160" y="609840"/>
+            <a:ext cx="5352840" cy="720720"/>
           </a:xfrm>
           <a:prstGeom prst="rect">
             <a:avLst/>
@@ -409,10 +400,7 @@
           </a:bodyPr>
           <a:p>
             <a:endParaRPr b="0" lang="en-US" sz="3200" spc="-1" strike="noStrike">
-              <a:solidFill>
-                <a:srgbClr val="000000"/>
-              </a:solidFill>
-              <a:latin typeface="Calibri"/>
+              <a:latin typeface="Arial"/>
             </a:endParaRPr>
           </a:p>
         </p:txBody>
@@ -429,8 +417,8 @@
         </p:nvSpPr>
         <p:spPr>
           <a:xfrm>
-            <a:off x="609120" y="1398600"/>
-            <a:ext cx="5352840" cy="720360"/>
+            <a:off x="609120" y="1399320"/>
+            <a:ext cx="5352840" cy="720720"/>
           </a:xfrm>
           <a:prstGeom prst="rect">
             <a:avLst/>
@@ -446,10 +434,7 @@
           </a:bodyPr>
           <a:p>
             <a:endParaRPr b="0" lang="en-US" sz="3200" spc="-1" strike="noStrike">
-              <a:solidFill>
-                <a:srgbClr val="000000"/>
-              </a:solidFill>
-              <a:latin typeface="Calibri"/>
+              <a:latin typeface="Arial"/>
             </a:endParaRPr>
           </a:p>
         </p:txBody>
@@ -466,8 +451,8 @@
         </p:nvSpPr>
         <p:spPr>
           <a:xfrm>
-            <a:off x="6230160" y="1398600"/>
-            <a:ext cx="5352840" cy="720360"/>
+            <a:off x="6230160" y="1399320"/>
+            <a:ext cx="5352840" cy="720720"/>
           </a:xfrm>
           <a:prstGeom prst="rect">
             <a:avLst/>
@@ -483,10 +468,7 @@
           </a:bodyPr>
           <a:p>
             <a:endParaRPr b="0" lang="en-US" sz="3200" spc="-1" strike="noStrike">
-              <a:solidFill>
-                <a:srgbClr val="000000"/>
-              </a:solidFill>
-              <a:latin typeface="Calibri"/>
+              <a:latin typeface="Arial"/>
             </a:endParaRPr>
           </a:p>
         </p:txBody>
@@ -498,7 +480,7 @@
             <a:spLocks noGrp="1"/>
           </p:cNvSpPr>
           <p:nvPr>
-            <p:ph type="ftr" idx="2"/>
+            <p:ph type="ftr" idx="1"/>
           </p:nvPr>
         </p:nvSpPr>
         <p:spPr/>
@@ -518,14 +500,14 @@
             <a:spLocks noGrp="1"/>
           </p:cNvSpPr>
           <p:nvPr>
-            <p:ph type="sldNum" idx="3"/>
+            <p:ph type="sldNum" idx="2"/>
           </p:nvPr>
         </p:nvSpPr>
         <p:spPr/>
         <p:txBody>
           <a:bodyPr/>
           <a:p>
-            <a:fld id="{E4762831-2E84-48BA-B89B-0E6FB4456017}" type="slidenum">
+            <a:fld id="{7351426C-B5C2-491A-B058-DBDDB525D3E7}" type="slidenum">
               <a:t>&lt;#&gt;</a:t>
             </a:fld>
           </a:p>
@@ -538,7 +520,7 @@
             <a:spLocks noGrp="1"/>
           </p:cNvSpPr>
           <p:nvPr>
-            <p:ph type="dt" idx="1"/>
+            <p:ph type="dt" idx="3"/>
           </p:nvPr>
         </p:nvSpPr>
         <p:spPr/>
@@ -586,8 +568,8 @@
         </p:nvSpPr>
         <p:spPr>
           <a:xfrm>
-            <a:off x="609120" y="103680"/>
-            <a:ext cx="10969560" cy="434520"/>
+            <a:off x="609120" y="8640"/>
+            <a:ext cx="10969560" cy="625320"/>
           </a:xfrm>
           <a:prstGeom prst="rect">
             <a:avLst/>
@@ -602,11 +584,11 @@
             <a:noAutofit/>
           </a:bodyPr>
           <a:p>
-            <a:endParaRPr b="0" lang="en-US" sz="1800" spc="-1" strike="noStrike">
-              <a:solidFill>
-                <a:srgbClr val="000000"/>
-              </a:solidFill>
-              <a:latin typeface="Calibri"/>
+            <a:pPr algn="ctr">
+              <a:buNone/>
+            </a:pPr>
+            <a:endParaRPr b="0" lang="en-US" sz="4400" spc="-1" strike="noStrike">
+              <a:latin typeface="Arial"/>
             </a:endParaRPr>
           </a:p>
         </p:txBody>
@@ -623,8 +605,8 @@
         </p:nvSpPr>
         <p:spPr>
           <a:xfrm>
-            <a:off x="609120" y="609480"/>
-            <a:ext cx="3531960" cy="720360"/>
+            <a:off x="609120" y="609840"/>
+            <a:ext cx="3531960" cy="720720"/>
           </a:xfrm>
           <a:prstGeom prst="rect">
             <a:avLst/>
@@ -640,10 +622,7 @@
           </a:bodyPr>
           <a:p>
             <a:endParaRPr b="0" lang="en-US" sz="3200" spc="-1" strike="noStrike">
-              <a:solidFill>
-                <a:srgbClr val="000000"/>
-              </a:solidFill>
-              <a:latin typeface="Calibri"/>
+              <a:latin typeface="Arial"/>
             </a:endParaRPr>
           </a:p>
         </p:txBody>
@@ -660,8 +639,8 @@
         </p:nvSpPr>
         <p:spPr>
           <a:xfrm>
-            <a:off x="4318200" y="609480"/>
-            <a:ext cx="3531960" cy="720360"/>
+            <a:off x="4318200" y="609840"/>
+            <a:ext cx="3531960" cy="720720"/>
           </a:xfrm>
           <a:prstGeom prst="rect">
             <a:avLst/>
@@ -677,10 +656,7 @@
           </a:bodyPr>
           <a:p>
             <a:endParaRPr b="0" lang="en-US" sz="3200" spc="-1" strike="noStrike">
-              <a:solidFill>
-                <a:srgbClr val="000000"/>
-              </a:solidFill>
-              <a:latin typeface="Calibri"/>
+              <a:latin typeface="Arial"/>
             </a:endParaRPr>
           </a:p>
         </p:txBody>
@@ -697,8 +673,8 @@
         </p:nvSpPr>
         <p:spPr>
           <a:xfrm>
-            <a:off x="8026920" y="609480"/>
-            <a:ext cx="3531960" cy="720360"/>
+            <a:off x="8026920" y="609840"/>
+            <a:ext cx="3531960" cy="720720"/>
           </a:xfrm>
           <a:prstGeom prst="rect">
             <a:avLst/>
@@ -714,10 +690,7 @@
           </a:bodyPr>
           <a:p>
             <a:endParaRPr b="0" lang="en-US" sz="3200" spc="-1" strike="noStrike">
-              <a:solidFill>
-                <a:srgbClr val="000000"/>
-              </a:solidFill>
-              <a:latin typeface="Calibri"/>
+              <a:latin typeface="Arial"/>
             </a:endParaRPr>
           </a:p>
         </p:txBody>
@@ -734,8 +707,8 @@
         </p:nvSpPr>
         <p:spPr>
           <a:xfrm>
-            <a:off x="609120" y="1398600"/>
-            <a:ext cx="3531960" cy="720360"/>
+            <a:off x="609120" y="1399320"/>
+            <a:ext cx="3531960" cy="720720"/>
           </a:xfrm>
           <a:prstGeom prst="rect">
             <a:avLst/>
@@ -751,10 +724,7 @@
           </a:bodyPr>
           <a:p>
             <a:endParaRPr b="0" lang="en-US" sz="3200" spc="-1" strike="noStrike">
-              <a:solidFill>
-                <a:srgbClr val="000000"/>
-              </a:solidFill>
-              <a:latin typeface="Calibri"/>
+              <a:latin typeface="Arial"/>
             </a:endParaRPr>
           </a:p>
         </p:txBody>
@@ -771,8 +741,8 @@
         </p:nvSpPr>
         <p:spPr>
           <a:xfrm>
-            <a:off x="4318200" y="1398600"/>
-            <a:ext cx="3531960" cy="720360"/>
+            <a:off x="4318200" y="1399320"/>
+            <a:ext cx="3531960" cy="720720"/>
           </a:xfrm>
           <a:prstGeom prst="rect">
             <a:avLst/>
@@ -788,10 +758,7 @@
           </a:bodyPr>
           <a:p>
             <a:endParaRPr b="0" lang="en-US" sz="3200" spc="-1" strike="noStrike">
-              <a:solidFill>
-                <a:srgbClr val="000000"/>
-              </a:solidFill>
-              <a:latin typeface="Calibri"/>
+              <a:latin typeface="Arial"/>
             </a:endParaRPr>
           </a:p>
         </p:txBody>
@@ -808,8 +775,8 @@
         </p:nvSpPr>
         <p:spPr>
           <a:xfrm>
-            <a:off x="8026920" y="1398600"/>
-            <a:ext cx="3531960" cy="720360"/>
+            <a:off x="8026920" y="1399320"/>
+            <a:ext cx="3531960" cy="720720"/>
           </a:xfrm>
           <a:prstGeom prst="rect">
             <a:avLst/>
@@ -825,10 +792,7 @@
           </a:bodyPr>
           <a:p>
             <a:endParaRPr b="0" lang="en-US" sz="3200" spc="-1" strike="noStrike">
-              <a:solidFill>
-                <a:srgbClr val="000000"/>
-              </a:solidFill>
-              <a:latin typeface="Calibri"/>
+              <a:latin typeface="Arial"/>
             </a:endParaRPr>
           </a:p>
         </p:txBody>
@@ -840,7 +804,7 @@
             <a:spLocks noGrp="1"/>
           </p:cNvSpPr>
           <p:nvPr>
-            <p:ph type="ftr" idx="2"/>
+            <p:ph type="ftr" idx="1"/>
           </p:nvPr>
         </p:nvSpPr>
         <p:spPr/>
@@ -860,14 +824,14 @@
             <a:spLocks noGrp="1"/>
           </p:cNvSpPr>
           <p:nvPr>
-            <p:ph type="sldNum" idx="3"/>
+            <p:ph type="sldNum" idx="2"/>
           </p:nvPr>
         </p:nvSpPr>
         <p:spPr/>
         <p:txBody>
           <a:bodyPr/>
           <a:p>
-            <a:fld id="{F49B3877-C91C-4ABE-8ACC-5870A1E38A0E}" type="slidenum">
+            <a:fld id="{D7C36C10-65FA-4A0F-90D9-02495B88D768}" type="slidenum">
               <a:t>&lt;#&gt;</a:t>
             </a:fld>
           </a:p>
@@ -880,7 +844,7 @@
             <a:spLocks noGrp="1"/>
           </p:cNvSpPr>
           <p:nvPr>
-            <p:ph type="dt" idx="1"/>
+            <p:ph type="dt" idx="3"/>
           </p:nvPr>
         </p:nvSpPr>
         <p:spPr/>
@@ -928,8 +892,8 @@
         </p:nvSpPr>
         <p:spPr>
           <a:xfrm>
-            <a:off x="609120" y="103680"/>
-            <a:ext cx="10969560" cy="434520"/>
+            <a:off x="609120" y="8640"/>
+            <a:ext cx="10969560" cy="625320"/>
           </a:xfrm>
           <a:prstGeom prst="rect">
             <a:avLst/>
@@ -944,11 +908,11 @@
             <a:noAutofit/>
           </a:bodyPr>
           <a:p>
-            <a:endParaRPr b="0" lang="en-US" sz="1800" spc="-1" strike="noStrike">
-              <a:solidFill>
-                <a:srgbClr val="000000"/>
-              </a:solidFill>
-              <a:latin typeface="Calibri"/>
+            <a:pPr algn="ctr">
+              <a:buNone/>
+            </a:pPr>
+            <a:endParaRPr b="0" lang="en-US" sz="4400" spc="-1" strike="noStrike">
+              <a:latin typeface="Arial"/>
             </a:endParaRPr>
           </a:p>
         </p:txBody>
@@ -965,8 +929,8 @@
         </p:nvSpPr>
         <p:spPr>
           <a:xfrm>
-            <a:off x="609120" y="609480"/>
-            <a:ext cx="10969560" cy="1510920"/>
+            <a:off x="609120" y="609840"/>
+            <a:ext cx="10969560" cy="1511280"/>
           </a:xfrm>
           <a:prstGeom prst="rect">
             <a:avLst/>
@@ -997,7 +961,7 @@
             <a:spLocks noGrp="1"/>
           </p:cNvSpPr>
           <p:nvPr>
-            <p:ph type="ftr" idx="2"/>
+            <p:ph type="ftr" idx="1"/>
           </p:nvPr>
         </p:nvSpPr>
         <p:spPr/>
@@ -1017,14 +981,14 @@
             <a:spLocks noGrp="1"/>
           </p:cNvSpPr>
           <p:nvPr>
-            <p:ph type="sldNum" idx="3"/>
+            <p:ph type="sldNum" idx="2"/>
           </p:nvPr>
         </p:nvSpPr>
         <p:spPr/>
         <p:txBody>
           <a:bodyPr/>
           <a:p>
-            <a:fld id="{E50B0ECF-61CA-40B5-A9D2-A7FEE7E9109E}" type="slidenum">
+            <a:fld id="{A2E62B88-D60B-423C-8B6A-6919488D4DAD}" type="slidenum">
               <a:t>&lt;#&gt;</a:t>
             </a:fld>
           </a:p>
@@ -1037,7 +1001,7 @@
             <a:spLocks noGrp="1"/>
           </p:cNvSpPr>
           <p:nvPr>
-            <p:ph type="dt" idx="1"/>
+            <p:ph type="dt" idx="3"/>
           </p:nvPr>
         </p:nvSpPr>
         <p:spPr/>
@@ -1085,8 +1049,8 @@
         </p:nvSpPr>
         <p:spPr>
           <a:xfrm>
-            <a:off x="609120" y="103680"/>
-            <a:ext cx="10969560" cy="434520"/>
+            <a:off x="609120" y="8640"/>
+            <a:ext cx="10969560" cy="625320"/>
           </a:xfrm>
           <a:prstGeom prst="rect">
             <a:avLst/>
@@ -1101,11 +1065,11 @@
             <a:noAutofit/>
           </a:bodyPr>
           <a:p>
-            <a:endParaRPr b="0" lang="en-US" sz="1800" spc="-1" strike="noStrike">
-              <a:solidFill>
-                <a:srgbClr val="000000"/>
-              </a:solidFill>
-              <a:latin typeface="Calibri"/>
+            <a:pPr algn="ctr">
+              <a:buNone/>
+            </a:pPr>
+            <a:endParaRPr b="0" lang="en-US" sz="4400" spc="-1" strike="noStrike">
+              <a:latin typeface="Arial"/>
             </a:endParaRPr>
           </a:p>
         </p:txBody>
@@ -1122,8 +1086,8 @@
         </p:nvSpPr>
         <p:spPr>
           <a:xfrm>
-            <a:off x="609120" y="609480"/>
-            <a:ext cx="10969560" cy="1510920"/>
+            <a:off x="609120" y="609840"/>
+            <a:ext cx="10969560" cy="1511280"/>
           </a:xfrm>
           <a:prstGeom prst="rect">
             <a:avLst/>
@@ -1139,10 +1103,7 @@
           </a:bodyPr>
           <a:p>
             <a:endParaRPr b="0" lang="en-US" sz="3200" spc="-1" strike="noStrike">
-              <a:solidFill>
-                <a:srgbClr val="000000"/>
-              </a:solidFill>
-              <a:latin typeface="Calibri"/>
+              <a:latin typeface="Arial"/>
             </a:endParaRPr>
           </a:p>
         </p:txBody>
@@ -1154,7 +1115,7 @@
             <a:spLocks noGrp="1"/>
           </p:cNvSpPr>
           <p:nvPr>
-            <p:ph type="ftr" idx="2"/>
+            <p:ph type="ftr" idx="1"/>
           </p:nvPr>
         </p:nvSpPr>
         <p:spPr/>
@@ -1174,14 +1135,14 @@
             <a:spLocks noGrp="1"/>
           </p:cNvSpPr>
           <p:nvPr>
-            <p:ph type="sldNum" idx="3"/>
+            <p:ph type="sldNum" idx="2"/>
           </p:nvPr>
         </p:nvSpPr>
         <p:spPr/>
         <p:txBody>
           <a:bodyPr/>
           <a:p>
-            <a:fld id="{AE339456-4EF5-4DAA-AC47-238A0194A592}" type="slidenum">
+            <a:fld id="{90FC91FE-3631-4D24-B746-C25F6ABFEE00}" type="slidenum">
               <a:t>&lt;#&gt;</a:t>
             </a:fld>
           </a:p>
@@ -1194,7 +1155,7 @@
             <a:spLocks noGrp="1"/>
           </p:cNvSpPr>
           <p:nvPr>
-            <p:ph type="dt" idx="1"/>
+            <p:ph type="dt" idx="3"/>
           </p:nvPr>
         </p:nvSpPr>
         <p:spPr/>
@@ -1242,8 +1203,8 @@
         </p:nvSpPr>
         <p:spPr>
           <a:xfrm>
-            <a:off x="609120" y="103680"/>
-            <a:ext cx="10969560" cy="434520"/>
+            <a:off x="609120" y="8640"/>
+            <a:ext cx="10969560" cy="625320"/>
           </a:xfrm>
           <a:prstGeom prst="rect">
             <a:avLst/>
@@ -1258,11 +1219,11 @@
             <a:noAutofit/>
           </a:bodyPr>
           <a:p>
-            <a:endParaRPr b="0" lang="en-US" sz="1800" spc="-1" strike="noStrike">
-              <a:solidFill>
-                <a:srgbClr val="000000"/>
-              </a:solidFill>
-              <a:latin typeface="Calibri"/>
+            <a:pPr algn="ctr">
+              <a:buNone/>
+            </a:pPr>
+            <a:endParaRPr b="0" lang="en-US" sz="4400" spc="-1" strike="noStrike">
+              <a:latin typeface="Arial"/>
             </a:endParaRPr>
           </a:p>
         </p:txBody>
@@ -1279,8 +1240,8 @@
         </p:nvSpPr>
         <p:spPr>
           <a:xfrm>
-            <a:off x="609120" y="609480"/>
-            <a:ext cx="5352840" cy="1510920"/>
+            <a:off x="609120" y="609840"/>
+            <a:ext cx="5352840" cy="1511280"/>
           </a:xfrm>
           <a:prstGeom prst="rect">
             <a:avLst/>
@@ -1296,10 +1257,7 @@
           </a:bodyPr>
           <a:p>
             <a:endParaRPr b="0" lang="en-US" sz="3200" spc="-1" strike="noStrike">
-              <a:solidFill>
-                <a:srgbClr val="000000"/>
-              </a:solidFill>
-              <a:latin typeface="Calibri"/>
+              <a:latin typeface="Arial"/>
             </a:endParaRPr>
           </a:p>
         </p:txBody>
@@ -1316,8 +1274,8 @@
         </p:nvSpPr>
         <p:spPr>
           <a:xfrm>
-            <a:off x="6230160" y="609480"/>
-            <a:ext cx="5352840" cy="1510920"/>
+            <a:off x="6230160" y="609840"/>
+            <a:ext cx="5352840" cy="1511280"/>
           </a:xfrm>
           <a:prstGeom prst="rect">
             <a:avLst/>
@@ -1333,10 +1291,7 @@
           </a:bodyPr>
           <a:p>
             <a:endParaRPr b="0" lang="en-US" sz="3200" spc="-1" strike="noStrike">
-              <a:solidFill>
-                <a:srgbClr val="000000"/>
-              </a:solidFill>
-              <a:latin typeface="Calibri"/>
+              <a:latin typeface="Arial"/>
             </a:endParaRPr>
           </a:p>
         </p:txBody>
@@ -1348,7 +1303,7 @@
             <a:spLocks noGrp="1"/>
           </p:cNvSpPr>
           <p:nvPr>
-            <p:ph type="ftr" idx="2"/>
+            <p:ph type="ftr" idx="1"/>
           </p:nvPr>
         </p:nvSpPr>
         <p:spPr/>
@@ -1368,14 +1323,14 @@
             <a:spLocks noGrp="1"/>
           </p:cNvSpPr>
           <p:nvPr>
-            <p:ph type="sldNum" idx="3"/>
+            <p:ph type="sldNum" idx="2"/>
           </p:nvPr>
         </p:nvSpPr>
         <p:spPr/>
         <p:txBody>
           <a:bodyPr/>
           <a:p>
-            <a:fld id="{E0A5CC84-3A63-4ADB-B25D-B7A287E9B6BE}" type="slidenum">
+            <a:fld id="{44F4380B-9ACE-4C42-9B10-D55B83822FD8}" type="slidenum">
               <a:t>&lt;#&gt;</a:t>
             </a:fld>
           </a:p>
@@ -1388,7 +1343,7 @@
             <a:spLocks noGrp="1"/>
           </p:cNvSpPr>
           <p:nvPr>
-            <p:ph type="dt" idx="1"/>
+            <p:ph type="dt" idx="3"/>
           </p:nvPr>
         </p:nvSpPr>
         <p:spPr/>
@@ -1436,8 +1391,8 @@
         </p:nvSpPr>
         <p:spPr>
           <a:xfrm>
-            <a:off x="609120" y="103680"/>
-            <a:ext cx="10969560" cy="434520"/>
+            <a:off x="609120" y="8640"/>
+            <a:ext cx="10969560" cy="625320"/>
           </a:xfrm>
           <a:prstGeom prst="rect">
             <a:avLst/>
@@ -1452,11 +1407,11 @@
             <a:noAutofit/>
           </a:bodyPr>
           <a:p>
-            <a:endParaRPr b="0" lang="en-US" sz="1800" spc="-1" strike="noStrike">
-              <a:solidFill>
-                <a:srgbClr val="000000"/>
-              </a:solidFill>
-              <a:latin typeface="Calibri"/>
+            <a:pPr algn="ctr">
+              <a:buNone/>
+            </a:pPr>
+            <a:endParaRPr b="0" lang="en-US" sz="4400" spc="-1" strike="noStrike">
+              <a:latin typeface="Arial"/>
             </a:endParaRPr>
           </a:p>
         </p:txBody>
@@ -1468,7 +1423,7 @@
             <a:spLocks noGrp="1"/>
           </p:cNvSpPr>
           <p:nvPr>
-            <p:ph type="ftr" idx="2"/>
+            <p:ph type="ftr" idx="1"/>
           </p:nvPr>
         </p:nvSpPr>
         <p:spPr/>
@@ -1488,14 +1443,14 @@
             <a:spLocks noGrp="1"/>
           </p:cNvSpPr>
           <p:nvPr>
-            <p:ph type="sldNum" idx="3"/>
+            <p:ph type="sldNum" idx="2"/>
           </p:nvPr>
         </p:nvSpPr>
         <p:spPr/>
         <p:txBody>
           <a:bodyPr/>
           <a:p>
-            <a:fld id="{4ED5C607-7FDE-4269-AEE4-C6773EECFB08}" type="slidenum">
+            <a:fld id="{7F698202-F546-4ABE-9996-641E2D9E3450}" type="slidenum">
               <a:t>&lt;#&gt;</a:t>
             </a:fld>
           </a:p>
@@ -1508,7 +1463,7 @@
             <a:spLocks noGrp="1"/>
           </p:cNvSpPr>
           <p:nvPr>
-            <p:ph type="dt" idx="1"/>
+            <p:ph type="dt" idx="3"/>
           </p:nvPr>
         </p:nvSpPr>
         <p:spPr/>
@@ -1557,7 +1512,7 @@
         <p:spPr>
           <a:xfrm>
             <a:off x="609120" y="103680"/>
-            <a:ext cx="10969560" cy="2015640"/>
+            <a:ext cx="10969560" cy="2017080"/>
           </a:xfrm>
           <a:prstGeom prst="rect">
             <a:avLst/>
@@ -1588,7 +1543,7 @@
             <a:spLocks noGrp="1"/>
           </p:cNvSpPr>
           <p:nvPr>
-            <p:ph type="ftr" idx="2"/>
+            <p:ph type="ftr" idx="1"/>
           </p:nvPr>
         </p:nvSpPr>
         <p:spPr/>
@@ -1608,14 +1563,14 @@
             <a:spLocks noGrp="1"/>
           </p:cNvSpPr>
           <p:nvPr>
-            <p:ph type="sldNum" idx="3"/>
+            <p:ph type="sldNum" idx="2"/>
           </p:nvPr>
         </p:nvSpPr>
         <p:spPr/>
         <p:txBody>
           <a:bodyPr/>
           <a:p>
-            <a:fld id="{2276B4C4-0BBC-4623-B035-0CF89EBE40E0}" type="slidenum">
+            <a:fld id="{A1BEFCA6-B5A8-47EE-8A4D-F9BB1A379C7E}" type="slidenum">
               <a:t>&lt;#&gt;</a:t>
             </a:fld>
           </a:p>
@@ -1628,7 +1583,7 @@
             <a:spLocks noGrp="1"/>
           </p:cNvSpPr>
           <p:nvPr>
-            <p:ph type="dt" idx="1"/>
+            <p:ph type="dt" idx="3"/>
           </p:nvPr>
         </p:nvSpPr>
         <p:spPr/>
@@ -1676,8 +1631,8 @@
         </p:nvSpPr>
         <p:spPr>
           <a:xfrm>
-            <a:off x="609120" y="103680"/>
-            <a:ext cx="10969560" cy="434520"/>
+            <a:off x="609120" y="8640"/>
+            <a:ext cx="10969560" cy="625320"/>
           </a:xfrm>
           <a:prstGeom prst="rect">
             <a:avLst/>
@@ -1692,11 +1647,11 @@
             <a:noAutofit/>
           </a:bodyPr>
           <a:p>
-            <a:endParaRPr b="0" lang="en-US" sz="1800" spc="-1" strike="noStrike">
-              <a:solidFill>
-                <a:srgbClr val="000000"/>
-              </a:solidFill>
-              <a:latin typeface="Calibri"/>
+            <a:pPr algn="ctr">
+              <a:buNone/>
+            </a:pPr>
+            <a:endParaRPr b="0" lang="en-US" sz="4400" spc="-1" strike="noStrike">
+              <a:latin typeface="Arial"/>
             </a:endParaRPr>
           </a:p>
         </p:txBody>
@@ -1713,8 +1668,8 @@
         </p:nvSpPr>
         <p:spPr>
           <a:xfrm>
-            <a:off x="609120" y="609480"/>
-            <a:ext cx="5352840" cy="720360"/>
+            <a:off x="609120" y="609840"/>
+            <a:ext cx="5352840" cy="720720"/>
           </a:xfrm>
           <a:prstGeom prst="rect">
             <a:avLst/>
@@ -1730,10 +1685,7 @@
           </a:bodyPr>
           <a:p>
             <a:endParaRPr b="0" lang="en-US" sz="3200" spc="-1" strike="noStrike">
-              <a:solidFill>
-                <a:srgbClr val="000000"/>
-              </a:solidFill>
-              <a:latin typeface="Calibri"/>
+              <a:latin typeface="Arial"/>
             </a:endParaRPr>
           </a:p>
         </p:txBody>
@@ -1750,8 +1702,8 @@
         </p:nvSpPr>
         <p:spPr>
           <a:xfrm>
-            <a:off x="6230160" y="609480"/>
-            <a:ext cx="5352840" cy="1510920"/>
+            <a:off x="6230160" y="609840"/>
+            <a:ext cx="5352840" cy="1511280"/>
           </a:xfrm>
           <a:prstGeom prst="rect">
             <a:avLst/>
@@ -1767,10 +1719,7 @@
           </a:bodyPr>
           <a:p>
             <a:endParaRPr b="0" lang="en-US" sz="3200" spc="-1" strike="noStrike">
-              <a:solidFill>
-                <a:srgbClr val="000000"/>
-              </a:solidFill>
-              <a:latin typeface="Calibri"/>
+              <a:latin typeface="Arial"/>
             </a:endParaRPr>
           </a:p>
         </p:txBody>
@@ -1787,8 +1736,8 @@
         </p:nvSpPr>
         <p:spPr>
           <a:xfrm>
-            <a:off x="609120" y="1398600"/>
-            <a:ext cx="5352840" cy="720360"/>
+            <a:off x="609120" y="1399320"/>
+            <a:ext cx="5352840" cy="720720"/>
           </a:xfrm>
           <a:prstGeom prst="rect">
             <a:avLst/>
@@ -1804,10 +1753,7 @@
           </a:bodyPr>
           <a:p>
             <a:endParaRPr b="0" lang="en-US" sz="3200" spc="-1" strike="noStrike">
-              <a:solidFill>
-                <a:srgbClr val="000000"/>
-              </a:solidFill>
-              <a:latin typeface="Calibri"/>
+              <a:latin typeface="Arial"/>
             </a:endParaRPr>
           </a:p>
         </p:txBody>
@@ -1819,7 +1765,7 @@
             <a:spLocks noGrp="1"/>
           </p:cNvSpPr>
           <p:nvPr>
-            <p:ph type="ftr" idx="2"/>
+            <p:ph type="ftr" idx="1"/>
           </p:nvPr>
         </p:nvSpPr>
         <p:spPr/>
@@ -1839,14 +1785,14 @@
             <a:spLocks noGrp="1"/>
           </p:cNvSpPr>
           <p:nvPr>
-            <p:ph type="sldNum" idx="3"/>
+            <p:ph type="sldNum" idx="2"/>
           </p:nvPr>
         </p:nvSpPr>
         <p:spPr/>
         <p:txBody>
           <a:bodyPr/>
           <a:p>
-            <a:fld id="{96D44EDB-467E-4252-80FA-E9BF03C29F76}" type="slidenum">
+            <a:fld id="{3C403524-80B0-4ABA-BF6E-22C24A37D4FB}" type="slidenum">
               <a:t>&lt;#&gt;</a:t>
             </a:fld>
           </a:p>
@@ -1859,7 +1805,7 @@
             <a:spLocks noGrp="1"/>
           </p:cNvSpPr>
           <p:nvPr>
-            <p:ph type="dt" idx="1"/>
+            <p:ph type="dt" idx="3"/>
           </p:nvPr>
         </p:nvSpPr>
         <p:spPr/>
@@ -1907,8 +1853,8 @@
         </p:nvSpPr>
         <p:spPr>
           <a:xfrm>
-            <a:off x="609120" y="103680"/>
-            <a:ext cx="10969560" cy="434520"/>
+            <a:off x="609120" y="8640"/>
+            <a:ext cx="10969560" cy="625320"/>
           </a:xfrm>
           <a:prstGeom prst="rect">
             <a:avLst/>
@@ -1923,11 +1869,11 @@
             <a:noAutofit/>
           </a:bodyPr>
           <a:p>
-            <a:endParaRPr b="0" lang="en-US" sz="1800" spc="-1" strike="noStrike">
-              <a:solidFill>
-                <a:srgbClr val="000000"/>
-              </a:solidFill>
-              <a:latin typeface="Calibri"/>
+            <a:pPr algn="ctr">
+              <a:buNone/>
+            </a:pPr>
+            <a:endParaRPr b="0" lang="en-US" sz="4400" spc="-1" strike="noStrike">
+              <a:latin typeface="Arial"/>
             </a:endParaRPr>
           </a:p>
         </p:txBody>
@@ -1944,8 +1890,8 @@
         </p:nvSpPr>
         <p:spPr>
           <a:xfrm>
-            <a:off x="609120" y="609480"/>
-            <a:ext cx="5352840" cy="1510920"/>
+            <a:off x="609120" y="609840"/>
+            <a:ext cx="5352840" cy="1511280"/>
           </a:xfrm>
           <a:prstGeom prst="rect">
             <a:avLst/>
@@ -1961,10 +1907,7 @@
           </a:bodyPr>
           <a:p>
             <a:endParaRPr b="0" lang="en-US" sz="3200" spc="-1" strike="noStrike">
-              <a:solidFill>
-                <a:srgbClr val="000000"/>
-              </a:solidFill>
-              <a:latin typeface="Calibri"/>
+              <a:latin typeface="Arial"/>
             </a:endParaRPr>
           </a:p>
         </p:txBody>
@@ -1981,8 +1924,8 @@
         </p:nvSpPr>
         <p:spPr>
           <a:xfrm>
-            <a:off x="6230160" y="609480"/>
-            <a:ext cx="5352840" cy="720360"/>
+            <a:off x="6230160" y="609840"/>
+            <a:ext cx="5352840" cy="720720"/>
           </a:xfrm>
           <a:prstGeom prst="rect">
             <a:avLst/>
@@ -1998,10 +1941,7 @@
           </a:bodyPr>
           <a:p>
             <a:endParaRPr b="0" lang="en-US" sz="3200" spc="-1" strike="noStrike">
-              <a:solidFill>
-                <a:srgbClr val="000000"/>
-              </a:solidFill>
-              <a:latin typeface="Calibri"/>
+              <a:latin typeface="Arial"/>
             </a:endParaRPr>
           </a:p>
         </p:txBody>
@@ -2018,8 +1958,8 @@
         </p:nvSpPr>
         <p:spPr>
           <a:xfrm>
-            <a:off x="6230160" y="1398600"/>
-            <a:ext cx="5352840" cy="720360"/>
+            <a:off x="6230160" y="1399320"/>
+            <a:ext cx="5352840" cy="720720"/>
           </a:xfrm>
           <a:prstGeom prst="rect">
             <a:avLst/>
@@ -2035,10 +1975,7 @@
           </a:bodyPr>
           <a:p>
             <a:endParaRPr b="0" lang="en-US" sz="3200" spc="-1" strike="noStrike">
-              <a:solidFill>
-                <a:srgbClr val="000000"/>
-              </a:solidFill>
-              <a:latin typeface="Calibri"/>
+              <a:latin typeface="Arial"/>
             </a:endParaRPr>
           </a:p>
         </p:txBody>
@@ -2050,7 +1987,7 @@
             <a:spLocks noGrp="1"/>
           </p:cNvSpPr>
           <p:nvPr>
-            <p:ph type="ftr" idx="2"/>
+            <p:ph type="ftr" idx="1"/>
           </p:nvPr>
         </p:nvSpPr>
         <p:spPr/>
@@ -2070,14 +2007,14 @@
             <a:spLocks noGrp="1"/>
           </p:cNvSpPr>
           <p:nvPr>
-            <p:ph type="sldNum" idx="3"/>
+            <p:ph type="sldNum" idx="2"/>
           </p:nvPr>
         </p:nvSpPr>
         <p:spPr/>
         <p:txBody>
           <a:bodyPr/>
           <a:p>
-            <a:fld id="{AD197AF2-50EC-4CDC-BEB3-7562C1ADD63D}" type="slidenum">
+            <a:fld id="{11CD2E40-7F75-42CA-BF44-C7E0D2751240}" type="slidenum">
               <a:t>&lt;#&gt;</a:t>
             </a:fld>
           </a:p>
@@ -2090,7 +2027,7 @@
             <a:spLocks noGrp="1"/>
           </p:cNvSpPr>
           <p:nvPr>
-            <p:ph type="dt" idx="1"/>
+            <p:ph type="dt" idx="3"/>
           </p:nvPr>
         </p:nvSpPr>
         <p:spPr/>
@@ -2138,8 +2075,8 @@
         </p:nvSpPr>
         <p:spPr>
           <a:xfrm>
-            <a:off x="609120" y="103680"/>
-            <a:ext cx="10969560" cy="434520"/>
+            <a:off x="609120" y="8640"/>
+            <a:ext cx="10969560" cy="625320"/>
           </a:xfrm>
           <a:prstGeom prst="rect">
             <a:avLst/>
@@ -2154,11 +2091,11 @@
             <a:noAutofit/>
           </a:bodyPr>
           <a:p>
-            <a:endParaRPr b="0" lang="en-US" sz="1800" spc="-1" strike="noStrike">
-              <a:solidFill>
-                <a:srgbClr val="000000"/>
-              </a:solidFill>
-              <a:latin typeface="Calibri"/>
+            <a:pPr algn="ctr">
+              <a:buNone/>
+            </a:pPr>
+            <a:endParaRPr b="0" lang="en-US" sz="4400" spc="-1" strike="noStrike">
+              <a:latin typeface="Arial"/>
             </a:endParaRPr>
           </a:p>
         </p:txBody>
@@ -2175,8 +2112,8 @@
         </p:nvSpPr>
         <p:spPr>
           <a:xfrm>
-            <a:off x="609120" y="609480"/>
-            <a:ext cx="5352840" cy="720360"/>
+            <a:off x="609120" y="609840"/>
+            <a:ext cx="5352840" cy="720720"/>
           </a:xfrm>
           <a:prstGeom prst="rect">
             <a:avLst/>
@@ -2192,10 +2129,7 @@
           </a:bodyPr>
           <a:p>
             <a:endParaRPr b="0" lang="en-US" sz="3200" spc="-1" strike="noStrike">
-              <a:solidFill>
-                <a:srgbClr val="000000"/>
-              </a:solidFill>
-              <a:latin typeface="Calibri"/>
+              <a:latin typeface="Arial"/>
             </a:endParaRPr>
           </a:p>
         </p:txBody>
@@ -2212,8 +2146,8 @@
         </p:nvSpPr>
         <p:spPr>
           <a:xfrm>
-            <a:off x="6230160" y="609480"/>
-            <a:ext cx="5352840" cy="720360"/>
+            <a:off x="6230160" y="609840"/>
+            <a:ext cx="5352840" cy="720720"/>
           </a:xfrm>
           <a:prstGeom prst="rect">
             <a:avLst/>
@@ -2229,10 +2163,7 @@
           </a:bodyPr>
           <a:p>
             <a:endParaRPr b="0" lang="en-US" sz="3200" spc="-1" strike="noStrike">
-              <a:solidFill>
-                <a:srgbClr val="000000"/>
-              </a:solidFill>
-              <a:latin typeface="Calibri"/>
+              <a:latin typeface="Arial"/>
             </a:endParaRPr>
           </a:p>
         </p:txBody>
@@ -2249,8 +2180,8 @@
         </p:nvSpPr>
         <p:spPr>
           <a:xfrm>
-            <a:off x="609120" y="1398600"/>
-            <a:ext cx="10969560" cy="720360"/>
+            <a:off x="609120" y="1399320"/>
+            <a:ext cx="10969560" cy="720720"/>
           </a:xfrm>
           <a:prstGeom prst="rect">
             <a:avLst/>
@@ -2266,10 +2197,7 @@
           </a:bodyPr>
           <a:p>
             <a:endParaRPr b="0" lang="en-US" sz="3200" spc="-1" strike="noStrike">
-              <a:solidFill>
-                <a:srgbClr val="000000"/>
-              </a:solidFill>
-              <a:latin typeface="Calibri"/>
+              <a:latin typeface="Arial"/>
             </a:endParaRPr>
           </a:p>
         </p:txBody>
@@ -2281,7 +2209,7 @@
             <a:spLocks noGrp="1"/>
           </p:cNvSpPr>
           <p:nvPr>
-            <p:ph type="ftr" idx="2"/>
+            <p:ph type="ftr" idx="1"/>
           </p:nvPr>
         </p:nvSpPr>
         <p:spPr/>
@@ -2301,14 +2229,14 @@
             <a:spLocks noGrp="1"/>
           </p:cNvSpPr>
           <p:nvPr>
-            <p:ph type="sldNum" idx="3"/>
+            <p:ph type="sldNum" idx="2"/>
           </p:nvPr>
         </p:nvSpPr>
         <p:spPr/>
         <p:txBody>
           <a:bodyPr/>
           <a:p>
-            <a:fld id="{C93CF52C-AD91-48BB-AE63-F50AE3105B14}" type="slidenum">
+            <a:fld id="{D8CDE0B1-9B15-4754-89B5-7A844834274D}" type="slidenum">
               <a:t>&lt;#&gt;</a:t>
             </a:fld>
           </a:p>
@@ -2321,7 +2249,7 @@
             <a:spLocks noGrp="1"/>
           </p:cNvSpPr>
           <p:nvPr>
-            <p:ph type="dt" idx="1"/>
+            <p:ph type="dt" idx="3"/>
           </p:nvPr>
         </p:nvSpPr>
         <p:spPr/>
@@ -2371,13 +2299,13 @@
             <a:spLocks noGrp="1"/>
           </p:cNvSpPr>
           <p:nvPr>
-            <p:ph type="dt" idx="1"/>
-          </p:nvPr>
-        </p:nvSpPr>
-        <p:spPr>
-          <a:xfrm>
-            <a:off x="457200" y="6356520"/>
-            <a:ext cx="2133360" cy="364680"/>
+            <p:ph type="ftr" idx="1"/>
+          </p:nvPr>
+        </p:nvSpPr>
+        <p:spPr>
+          <a:xfrm>
+            <a:off x="3124080" y="6356520"/>
+            <a:ext cx="2894760" cy="364320"/>
           </a:xfrm>
           <a:prstGeom prst="rect">
             <a:avLst/>
@@ -2388,74 +2316,14 @@
           </a:ln>
         </p:spPr>
         <p:txBody>
-          <a:bodyPr anchor="ctr">
+          <a:bodyPr lIns="90000" rIns="90000" tIns="45000" bIns="45000" anchor="ctr">
             <a:noAutofit/>
           </a:bodyPr>
           <a:lstStyle>
-            <a:lvl1pPr>
+            <a:lvl1pPr algn="ctr">
               <a:lnSpc>
                 <a:spcPct val="100000"/>
               </a:lnSpc>
-              <a:buNone/>
-              <a:defRPr b="0" lang="en-US" sz="1200" spc="-1" strike="noStrike">
-                <a:solidFill>
-                  <a:srgbClr val="8b8b8b"/>
-                </a:solidFill>
-                <a:latin typeface="Calibri"/>
-              </a:defRPr>
-            </a:lvl1pPr>
-          </a:lstStyle>
-          <a:p>
-            <a:pPr>
-              <a:lnSpc>
-                <a:spcPct val="100000"/>
-              </a:lnSpc>
-              <a:buNone/>
-            </a:pPr>
-            <a:r>
-              <a:rPr b="0" lang="en-US" sz="1200" spc="-1" strike="noStrike">
-                <a:solidFill>
-                  <a:srgbClr val="8b8b8b"/>
-                </a:solidFill>
-                <a:latin typeface="Calibri"/>
-              </a:rPr>
-              <a:t>&lt;date/time&gt;</a:t>
-            </a:r>
-            <a:endParaRPr b="0" lang="en-US" sz="1200" spc="-1" strike="noStrike">
-              <a:latin typeface="Times New Roman"/>
-            </a:endParaRPr>
-          </a:p>
-        </p:txBody>
-      </p:sp>
-      <p:sp>
-        <p:nvSpPr>
-          <p:cNvPr id="1" name="PlaceHolder 2"/>
-          <p:cNvSpPr>
-            <a:spLocks noGrp="1"/>
-          </p:cNvSpPr>
-          <p:nvPr>
-            <p:ph type="ftr" idx="2"/>
-          </p:nvPr>
-        </p:nvSpPr>
-        <p:spPr>
-          <a:xfrm>
-            <a:off x="3124080" y="6356520"/>
-            <a:ext cx="2895120" cy="364680"/>
-          </a:xfrm>
-          <a:prstGeom prst="rect">
-            <a:avLst/>
-          </a:prstGeom>
-          <a:noFill/>
-          <a:ln w="0">
-            <a:noFill/>
-          </a:ln>
-        </p:spPr>
-        <p:txBody>
-          <a:bodyPr anchor="ctr">
-            <a:noAutofit/>
-          </a:bodyPr>
-          <a:lstStyle>
-            <a:lvl1pPr algn="ctr">
               <a:buNone/>
               <a:defRPr b="0" lang="en-US" sz="1400" spc="-1" strike="noStrike">
                 <a:latin typeface="Times New Roman"/>
@@ -2464,6 +2332,9 @@
           </a:lstStyle>
           <a:p>
             <a:pPr algn="ctr">
+              <a:lnSpc>
+                <a:spcPct val="100000"/>
+              </a:lnSpc>
               <a:buNone/>
             </a:pPr>
             <a:r>
@@ -2480,18 +2351,18 @@
       </p:sp>
       <p:sp>
         <p:nvSpPr>
-          <p:cNvPr id="2" name="PlaceHolder 3"/>
-          <p:cNvSpPr>
-            <a:spLocks noGrp="1"/>
-          </p:cNvSpPr>
-          <p:nvPr>
-            <p:ph type="sldNum" idx="3"/>
+          <p:cNvPr id="1" name="PlaceHolder 2"/>
+          <p:cNvSpPr>
+            <a:spLocks noGrp="1"/>
+          </p:cNvSpPr>
+          <p:nvPr>
+            <p:ph type="sldNum" idx="2"/>
           </p:nvPr>
         </p:nvSpPr>
         <p:spPr>
           <a:xfrm>
             <a:off x="6553080" y="6356520"/>
-            <a:ext cx="2133360" cy="364680"/>
+            <a:ext cx="2133000" cy="364320"/>
           </a:xfrm>
           <a:prstGeom prst="rect">
             <a:avLst/>
@@ -2502,7 +2373,7 @@
           </a:ln>
         </p:spPr>
         <p:txBody>
-          <a:bodyPr anchor="ctr">
+          <a:bodyPr lIns="90000" rIns="90000" tIns="45000" bIns="45000" anchor="ctr">
             <a:noAutofit/>
           </a:bodyPr>
           <a:lstStyle>
@@ -2526,7 +2397,7 @@
               </a:lnSpc>
               <a:buNone/>
             </a:pPr>
-            <a:fld id="{2FEB6382-BA72-4AC1-B068-59A5AAABE2B0}" type="slidenum">
+            <a:fld id="{4C1C40DD-E10E-4E71-840B-9C403CDE249C}" type="slidenum">
               <a:rPr b="0" lang="en-US" sz="1200" spc="-1" strike="noStrike">
                 <a:solidFill>
                   <a:srgbClr val="8b8b8b"/>
@@ -2536,6 +2407,53 @@
               <a:t>&lt;number&gt;</a:t>
             </a:fld>
             <a:endParaRPr b="0" lang="en-US" sz="1200" spc="-1" strike="noStrike">
+              <a:latin typeface="Times New Roman"/>
+            </a:endParaRPr>
+          </a:p>
+        </p:txBody>
+      </p:sp>
+      <p:sp>
+        <p:nvSpPr>
+          <p:cNvPr id="2" name="PlaceHolder 3"/>
+          <p:cNvSpPr>
+            <a:spLocks noGrp="1"/>
+          </p:cNvSpPr>
+          <p:nvPr>
+            <p:ph type="dt" idx="3"/>
+          </p:nvPr>
+        </p:nvSpPr>
+        <p:spPr>
+          <a:xfrm>
+            <a:off x="457200" y="6356520"/>
+            <a:ext cx="2133000" cy="364320"/>
+          </a:xfrm>
+          <a:prstGeom prst="rect">
+            <a:avLst/>
+          </a:prstGeom>
+          <a:noFill/>
+          <a:ln w="0">
+            <a:noFill/>
+          </a:ln>
+        </p:spPr>
+        <p:txBody>
+          <a:bodyPr lIns="90000" rIns="90000" tIns="45000" bIns="45000" anchor="ctr">
+            <a:noAutofit/>
+          </a:bodyPr>
+          <a:lstStyle>
+            <a:lvl1pPr>
+              <a:defRPr b="0" lang="en-US" sz="1400" spc="-1" strike="noStrike">
+                <a:latin typeface="Times New Roman"/>
+              </a:defRPr>
+            </a:lvl1pPr>
+          </a:lstStyle>
+          <a:p>
+            <a:r>
+              <a:rPr b="0" lang="en-US" sz="1400" spc="-1" strike="noStrike">
+                <a:latin typeface="Times New Roman"/>
+              </a:rPr>
+              <a:t>&lt;date/time&gt;</a:t>
+            </a:r>
+            <a:endParaRPr b="0" lang="en-US" sz="1400" spc="-1" strike="noStrike">
               <a:latin typeface="Times New Roman"/>
             </a:endParaRPr>
           </a:p>
@@ -2587,7 +2505,7 @@
         <p:spPr>
           <a:xfrm>
             <a:off x="91440" y="116640"/>
-            <a:ext cx="2468520" cy="168120"/>
+            <a:ext cx="2468160" cy="167760"/>
           </a:xfrm>
           <a:prstGeom prst="rect">
             <a:avLst/>
@@ -2620,11 +2538,12 @@
                   <a:srgbClr val="16213a"/>
                 </a:solidFill>
                 <a:latin typeface="Times New Roman"/>
+                <a:ea typeface="DejaVu Sans"/>
               </a:rPr>
               <a:t>(a) Nested STL spec</a:t>
             </a:r>
             <a:endParaRPr b="0" lang="en-US" sz="1100" spc="-1" strike="noStrike">
-              <a:latin typeface="Times New Roman"/>
+              <a:latin typeface="Arial"/>
             </a:endParaRPr>
           </a:p>
         </p:txBody>
@@ -2910,7 +2829,7 @@
         <p:spPr>
           <a:xfrm>
             <a:off x="1147680" y="744480"/>
-            <a:ext cx="365400" cy="365400"/>
+            <a:ext cx="365040" cy="365040"/>
           </a:xfrm>
           <a:prstGeom prst="ellipse">
             <a:avLst/>
@@ -2956,15 +2875,16 @@
               <a:buNone/>
             </a:pPr>
             <a:r>
-              <a:rPr b="1" lang="en-US" sz="800" spc="-1" strike="noStrike">
+              <a:rPr b="1" lang="en-US" sz="900" spc="-1" strike="noStrike">
                 <a:solidFill>
                   <a:srgbClr val="16213a"/>
                 </a:solidFill>
                 <a:latin typeface="Times New Roman"/>
+                <a:ea typeface="DejaVu Sans"/>
               </a:rPr>
               <a:t>∧</a:t>
             </a:r>
-            <a:endParaRPr b="0" lang="en-US" sz="800" spc="-1" strike="noStrike">
+            <a:endParaRPr b="0" lang="en-US" sz="900" spc="-1" strike="noStrike">
               <a:latin typeface="Times New Roman"/>
             </a:endParaRPr>
           </a:p>
@@ -2979,7 +2899,7 @@
         <p:spPr>
           <a:xfrm>
             <a:off x="541440" y="1220040"/>
-            <a:ext cx="365400" cy="365400"/>
+            <a:ext cx="365040" cy="365040"/>
           </a:xfrm>
           <a:prstGeom prst="ellipse">
             <a:avLst/>
@@ -3025,15 +2945,16 @@
               <a:buNone/>
             </a:pPr>
             <a:r>
-              <a:rPr b="1" lang="en-US" sz="800" spc="-1" strike="noStrike">
+              <a:rPr b="1" lang="en-US" sz="900" spc="-1" strike="noStrike">
                 <a:solidFill>
                   <a:srgbClr val="16213a"/>
                 </a:solidFill>
                 <a:latin typeface="Times New Roman"/>
+                <a:ea typeface="DejaVu Sans"/>
               </a:rPr>
               <a:t>F[a,b]</a:t>
             </a:r>
-            <a:endParaRPr b="0" lang="en-US" sz="800" spc="-1" strike="noStrike">
+            <a:endParaRPr b="0" lang="en-US" sz="900" spc="-1" strike="noStrike">
               <a:latin typeface="Times New Roman"/>
             </a:endParaRPr>
           </a:p>
@@ -3048,7 +2969,7 @@
         <p:spPr>
           <a:xfrm>
             <a:off x="541440" y="1732320"/>
-            <a:ext cx="365400" cy="365400"/>
+            <a:ext cx="365040" cy="365040"/>
           </a:xfrm>
           <a:prstGeom prst="ellipse">
             <a:avLst/>
@@ -3094,15 +3015,16 @@
               <a:buNone/>
             </a:pPr>
             <a:r>
-              <a:rPr b="1" lang="en-US" sz="800" spc="-1" strike="noStrike">
+              <a:rPr b="1" lang="en-US" sz="900" spc="-1" strike="noStrike">
                 <a:solidFill>
                   <a:srgbClr val="ffffff"/>
                 </a:solidFill>
                 <a:latin typeface="Times New Roman"/>
+                <a:ea typeface="DejaVu Sans"/>
               </a:rPr>
               <a:t>reach g</a:t>
             </a:r>
-            <a:endParaRPr b="0" lang="en-US" sz="800" spc="-1" strike="noStrike">
+            <a:endParaRPr b="0" lang="en-US" sz="900" spc="-1" strike="noStrike">
               <a:latin typeface="Times New Roman"/>
             </a:endParaRPr>
           </a:p>
@@ -3117,7 +3039,7 @@
         <p:spPr>
           <a:xfrm>
             <a:off x="1147680" y="1220040"/>
-            <a:ext cx="365400" cy="365400"/>
+            <a:ext cx="365040" cy="365040"/>
           </a:xfrm>
           <a:prstGeom prst="ellipse">
             <a:avLst/>
@@ -3163,15 +3085,16 @@
               <a:buNone/>
             </a:pPr>
             <a:r>
-              <a:rPr b="1" lang="en-US" sz="800" spc="-1" strike="noStrike">
+              <a:rPr b="1" lang="en-US" sz="900" spc="-1" strike="noStrike">
                 <a:solidFill>
                   <a:srgbClr val="16213a"/>
                 </a:solidFill>
                 <a:latin typeface="Times New Roman"/>
+                <a:ea typeface="DejaVu Sans"/>
               </a:rPr>
               <a:t>G</a:t>
             </a:r>
-            <a:endParaRPr b="0" lang="en-US" sz="800" spc="-1" strike="noStrike">
+            <a:endParaRPr b="0" lang="en-US" sz="900" spc="-1" strike="noStrike">
               <a:latin typeface="Times New Roman"/>
             </a:endParaRPr>
           </a:p>
@@ -3186,7 +3109,7 @@
         <p:spPr>
           <a:xfrm>
             <a:off x="1147680" y="1622520"/>
-            <a:ext cx="365400" cy="365400"/>
+            <a:ext cx="365040" cy="365040"/>
           </a:xfrm>
           <a:prstGeom prst="ellipse">
             <a:avLst/>
@@ -3232,15 +3155,16 @@
               <a:buNone/>
             </a:pPr>
             <a:r>
-              <a:rPr b="1" lang="en-US" sz="800" spc="-1" strike="noStrike">
+              <a:rPr b="1" lang="en-US" sz="900" spc="-1" strike="noStrike">
                 <a:solidFill>
                   <a:srgbClr val="16213a"/>
                 </a:solidFill>
                 <a:latin typeface="Times New Roman"/>
+                <a:ea typeface="DejaVu Sans"/>
               </a:rPr>
               <a:t>¬</a:t>
             </a:r>
-            <a:endParaRPr b="0" lang="en-US" sz="800" spc="-1" strike="noStrike">
+            <a:endParaRPr b="0" lang="en-US" sz="900" spc="-1" strike="noStrike">
               <a:latin typeface="Times New Roman"/>
             </a:endParaRPr>
           </a:p>
@@ -3255,7 +3179,7 @@
         <p:spPr>
           <a:xfrm>
             <a:off x="1147680" y="2024640"/>
-            <a:ext cx="365400" cy="365400"/>
+            <a:ext cx="365040" cy="365040"/>
           </a:xfrm>
           <a:prstGeom prst="ellipse">
             <a:avLst/>
@@ -3306,11 +3230,12 @@
                   <a:srgbClr val="ffffff"/>
                 </a:solidFill>
                 <a:latin typeface="Times New Roman"/>
+                <a:ea typeface="DejaVu Sans"/>
               </a:rPr>
               <a:t>avoid o</a:t>
             </a:r>
             <a:endParaRPr b="0" lang="en-US" sz="800" spc="-1" strike="noStrike">
-              <a:latin typeface="Times New Roman"/>
+              <a:latin typeface="Arial"/>
             </a:endParaRPr>
           </a:p>
         </p:txBody>
@@ -3324,7 +3249,7 @@
         <p:spPr>
           <a:xfrm>
             <a:off x="1800360" y="1220040"/>
-            <a:ext cx="365400" cy="365400"/>
+            <a:ext cx="365040" cy="365040"/>
           </a:xfrm>
           <a:prstGeom prst="ellipse">
             <a:avLst/>
@@ -3370,15 +3295,16 @@
               <a:buNone/>
             </a:pPr>
             <a:r>
-              <a:rPr b="1" lang="en-US" sz="800" spc="-1" strike="noStrike">
+              <a:rPr b="1" lang="en-US" sz="900" spc="-1" strike="noStrike">
                 <a:solidFill>
                   <a:srgbClr val="16213a"/>
                 </a:solidFill>
                 <a:latin typeface="Times New Roman"/>
+                <a:ea typeface="DejaVu Sans"/>
               </a:rPr>
               <a:t>G</a:t>
             </a:r>
-            <a:endParaRPr b="0" lang="en-US" sz="800" spc="-1" strike="noStrike">
+            <a:endParaRPr b="0" lang="en-US" sz="900" spc="-1" strike="noStrike">
               <a:latin typeface="Times New Roman"/>
             </a:endParaRPr>
           </a:p>
@@ -3393,7 +3319,7 @@
         <p:spPr>
           <a:xfrm>
             <a:off x="1800360" y="1622520"/>
-            <a:ext cx="365400" cy="365400"/>
+            <a:ext cx="365040" cy="365040"/>
           </a:xfrm>
           <a:prstGeom prst="ellipse">
             <a:avLst/>
@@ -3439,15 +3365,16 @@
               <a:buNone/>
             </a:pPr>
             <a:r>
-              <a:rPr b="1" lang="en-US" sz="800" spc="-1" strike="noStrike">
+              <a:rPr b="1" lang="en-US" sz="900" spc="-1" strike="noStrike">
                 <a:solidFill>
                   <a:srgbClr val="16213a"/>
                 </a:solidFill>
                 <a:latin typeface="Times New Roman"/>
+                <a:ea typeface="DejaVu Sans"/>
               </a:rPr>
               <a:t>¬</a:t>
             </a:r>
-            <a:endParaRPr b="0" lang="en-US" sz="800" spc="-1" strike="noStrike">
+            <a:endParaRPr b="0" lang="en-US" sz="900" spc="-1" strike="noStrike">
               <a:latin typeface="Times New Roman"/>
             </a:endParaRPr>
           </a:p>
@@ -3462,7 +3389,7 @@
         <p:spPr>
           <a:xfrm>
             <a:off x="1800360" y="2024640"/>
-            <a:ext cx="365400" cy="365400"/>
+            <a:ext cx="365040" cy="365040"/>
           </a:xfrm>
           <a:prstGeom prst="ellipse">
             <a:avLst/>
@@ -3513,11 +3440,12 @@
                   <a:srgbClr val="ffffff"/>
                 </a:solidFill>
                 <a:latin typeface="Times New Roman"/>
+                <a:ea typeface="DejaVu Sans"/>
               </a:rPr>
               <a:t>unsafe</a:t>
             </a:r>
             <a:endParaRPr b="0" lang="en-US" sz="800" spc="-1" strike="noStrike">
-              <a:latin typeface="Times New Roman"/>
+              <a:latin typeface="Arial"/>
             </a:endParaRPr>
           </a:p>
         </p:txBody>
@@ -3530,8 +3458,8 @@
         </p:nvSpPr>
         <p:spPr>
           <a:xfrm>
-            <a:off x="228600" y="421200"/>
-            <a:ext cx="2468520" cy="122400"/>
+            <a:off x="156600" y="414000"/>
+            <a:ext cx="2468160" cy="136440"/>
           </a:xfrm>
           <a:prstGeom prst="rect">
             <a:avLst/>
@@ -3553,18 +3481,22 @@
           </a:bodyPr>
           <a:p>
             <a:pPr algn="ctr">
+              <a:lnSpc>
+                <a:spcPct val="100000"/>
+              </a:lnSpc>
               <a:buNone/>
             </a:pPr>
             <a:r>
-              <a:rPr b="1" lang="en-US" sz="800" spc="-1" strike="noStrike">
+              <a:rPr b="1" lang="en-US" sz="900" spc="-1" strike="noStrike">
                 <a:solidFill>
                   <a:srgbClr val="16213a"/>
                 </a:solidFill>
                 <a:latin typeface="Times New Roman"/>
+                <a:ea typeface="DejaVu Sans"/>
               </a:rPr>
               <a:t>keep-safe = G ¬ unsafe, grounded by sensed disks</a:t>
             </a:r>
-            <a:endParaRPr b="0" lang="en-US" sz="800" spc="-1" strike="noStrike">
+            <a:endParaRPr b="0" lang="en-US" sz="900" spc="-1" strike="noStrike">
               <a:latin typeface="Arial"/>
             </a:endParaRPr>
           </a:p>
@@ -3579,7 +3511,7 @@
         <p:spPr>
           <a:xfrm>
             <a:off x="2788920" y="116640"/>
-            <a:ext cx="4434480" cy="168120"/>
+            <a:ext cx="4434120" cy="167760"/>
           </a:xfrm>
           <a:prstGeom prst="rect">
             <a:avLst/>
@@ -3612,11 +3544,12 @@
                   <a:srgbClr val="16213a"/>
                 </a:solidFill>
                 <a:latin typeface="Times New Roman"/>
+                <a:ea typeface="DejaVu Sans"/>
               </a:rPr>
               <a:t>(b) Frozen flow-matching planner + robustness guidance</a:t>
             </a:r>
             <a:endParaRPr b="0" lang="en-US" sz="1100" spc="-1" strike="noStrike">
-              <a:latin typeface="Times New Roman"/>
+              <a:latin typeface="Arial"/>
             </a:endParaRPr>
           </a:p>
         </p:txBody>
@@ -3630,7 +3563,7 @@
         <p:spPr>
           <a:xfrm>
             <a:off x="2833200" y="416880"/>
-            <a:ext cx="1197000" cy="520920"/>
+            <a:ext cx="1196640" cy="520560"/>
           </a:xfrm>
           <a:prstGeom prst="roundRect">
             <a:avLst>
@@ -3678,15 +3611,16 @@
               <a:buNone/>
             </a:pPr>
             <a:r>
-              <a:rPr b="1" lang="en-US" sz="800" spc="-1" strike="noStrike">
+              <a:rPr b="1" lang="en-US" sz="900" spc="-1" strike="noStrike">
                 <a:solidFill>
                   <a:srgbClr val="16213a"/>
                 </a:solidFill>
                 <a:latin typeface="Times New Roman"/>
+                <a:ea typeface="DejaVu Sans"/>
               </a:rPr>
               <a:t>frozen GNN</a:t>
             </a:r>
-            <a:endParaRPr b="0" lang="en-US" sz="800" spc="-1" strike="noStrike">
+            <a:endParaRPr b="0" lang="en-US" sz="900" spc="-1" strike="noStrike">
               <a:latin typeface="Times New Roman"/>
             </a:endParaRPr>
           </a:p>
@@ -3698,15 +3632,16 @@
               <a:buNone/>
             </a:pPr>
             <a:r>
-              <a:rPr b="1" lang="en-US" sz="800" spc="-1" strike="noStrike">
+              <a:rPr b="1" lang="en-US" sz="900" spc="-1" strike="noStrike">
                 <a:solidFill>
                   <a:srgbClr val="16213a"/>
                 </a:solidFill>
                 <a:latin typeface="Times New Roman"/>
+                <a:ea typeface="DejaVu Sans"/>
               </a:rPr>
               <a:t>encoder</a:t>
             </a:r>
-            <a:endParaRPr b="0" lang="en-US" sz="800" spc="-1" strike="noStrike">
+            <a:endParaRPr b="0" lang="en-US" sz="900" spc="-1" strike="noStrike">
               <a:latin typeface="Times New Roman"/>
             </a:endParaRPr>
           </a:p>
@@ -3720,8 +3655,8 @@
         </p:nvSpPr>
         <p:spPr>
           <a:xfrm>
-            <a:off x="2883240" y="1020600"/>
-            <a:ext cx="1096920" cy="120960"/>
+            <a:off x="2883240" y="1013040"/>
+            <a:ext cx="1096560" cy="136440"/>
           </a:xfrm>
           <a:prstGeom prst="rect">
             <a:avLst/>
@@ -3749,24 +3684,26 @@
               <a:buNone/>
             </a:pPr>
             <a:r>
-              <a:rPr b="1" lang="en-US" sz="800" spc="-1" strike="noStrike">
+              <a:rPr b="1" lang="en-US" sz="900" spc="-1" strike="noStrike">
                 <a:solidFill>
                   <a:srgbClr val="16213a"/>
                 </a:solidFill>
                 <a:latin typeface="Times New Roman"/>
+                <a:ea typeface="DejaVu Sans"/>
               </a:rPr>
               <a:t>⇒ </a:t>
             </a:r>
             <a:r>
-              <a:rPr b="1" lang="en-US" sz="800" spc="-1" strike="noStrike">
+              <a:rPr b="1" lang="en-US" sz="900" spc="-1" strike="noStrike">
                 <a:solidFill>
                   <a:srgbClr val="16213a"/>
                 </a:solidFill>
                 <a:latin typeface="Times New Roman"/>
+                <a:ea typeface="DejaVu Sans"/>
               </a:rPr>
               <a:t>conditioning z</a:t>
             </a:r>
-            <a:endParaRPr b="0" lang="en-US" sz="800" spc="-1" strike="noStrike">
+            <a:endParaRPr b="0" lang="en-US" sz="900" spc="-1" strike="noStrike">
               <a:latin typeface="Times New Roman"/>
             </a:endParaRPr>
           </a:p>
@@ -3781,7 +3718,7 @@
         <p:spPr>
           <a:xfrm>
             <a:off x="4030560" y="677520"/>
-            <a:ext cx="594360" cy="360"/>
+            <a:ext cx="632520" cy="0"/>
           </a:xfrm>
           <a:prstGeom prst="line">
             <a:avLst/>
@@ -3816,7 +3753,7 @@
         <p:spPr>
           <a:xfrm>
             <a:off x="4663080" y="467280"/>
-            <a:ext cx="420120" cy="420120"/>
+            <a:ext cx="419760" cy="419760"/>
           </a:xfrm>
           <a:prstGeom prst="ellipse">
             <a:avLst/>
@@ -3862,15 +3799,16 @@
               <a:buNone/>
             </a:pPr>
             <a:r>
-              <a:rPr b="1" lang="en-US" sz="800" spc="-1" strike="noStrike">
+              <a:rPr b="1" lang="en-US" sz="900" spc="-1" strike="noStrike">
                 <a:solidFill>
                   <a:srgbClr val="16213a"/>
                 </a:solidFill>
                 <a:latin typeface="Times New Roman"/>
+                <a:ea typeface="DejaVu Sans"/>
               </a:rPr>
               <a:t>xT</a:t>
             </a:r>
-            <a:endParaRPr b="0" lang="en-US" sz="800" spc="-1" strike="noStrike">
+            <a:endParaRPr b="0" lang="en-US" sz="900" spc="-1" strike="noStrike">
               <a:latin typeface="Times New Roman"/>
             </a:endParaRPr>
           </a:p>
@@ -3884,8 +3822,8 @@
         </p:nvSpPr>
         <p:spPr>
           <a:xfrm>
-            <a:off x="5139360" y="677520"/>
-            <a:ext cx="132840" cy="360"/>
+            <a:off x="5082840" y="685800"/>
+            <a:ext cx="245520" cy="0"/>
           </a:xfrm>
           <a:prstGeom prst="line">
             <a:avLst/>
@@ -3920,7 +3858,7 @@
         <p:spPr>
           <a:xfrm>
             <a:off x="5328360" y="467280"/>
-            <a:ext cx="420120" cy="420120"/>
+            <a:ext cx="419760" cy="419760"/>
           </a:xfrm>
           <a:prstGeom prst="ellipse">
             <a:avLst/>
@@ -3966,15 +3904,16 @@
               <a:buNone/>
             </a:pPr>
             <a:r>
-              <a:rPr b="1" lang="en-US" sz="800" spc="-1" strike="noStrike">
+              <a:rPr b="1" lang="en-US" sz="900" spc="-1" strike="noStrike">
                 <a:solidFill>
                   <a:srgbClr val="16213a"/>
                 </a:solidFill>
                 <a:latin typeface="Times New Roman"/>
+                <a:ea typeface="DejaVu Sans"/>
               </a:rPr>
               <a:t>xt</a:t>
             </a:r>
-            <a:endParaRPr b="0" lang="en-US" sz="800" spc="-1" strike="noStrike">
+            <a:endParaRPr b="0" lang="en-US" sz="900" spc="-1" strike="noStrike">
               <a:latin typeface="Times New Roman"/>
             </a:endParaRPr>
           </a:p>
@@ -3988,8 +3927,8 @@
         </p:nvSpPr>
         <p:spPr>
           <a:xfrm>
-            <a:off x="5804280" y="677520"/>
-            <a:ext cx="133200" cy="360"/>
+            <a:off x="5748120" y="685800"/>
+            <a:ext cx="245160" cy="0"/>
           </a:xfrm>
           <a:prstGeom prst="line">
             <a:avLst/>
@@ -4024,7 +3963,7 @@
         <p:spPr>
           <a:xfrm>
             <a:off x="5993280" y="467280"/>
-            <a:ext cx="420120" cy="420120"/>
+            <a:ext cx="419760" cy="419760"/>
           </a:xfrm>
           <a:prstGeom prst="ellipse">
             <a:avLst/>
@@ -4070,15 +4009,16 @@
               <a:buNone/>
             </a:pPr>
             <a:r>
-              <a:rPr b="1" lang="en-US" sz="800" spc="-1" strike="noStrike">
+              <a:rPr b="1" lang="en-US" sz="900" spc="-1" strike="noStrike">
                 <a:solidFill>
                   <a:srgbClr val="16213a"/>
                 </a:solidFill>
                 <a:latin typeface="Times New Roman"/>
+                <a:ea typeface="DejaVu Sans"/>
               </a:rPr>
               <a:t>⋯</a:t>
             </a:r>
-            <a:endParaRPr b="0" lang="en-US" sz="800" spc="-1" strike="noStrike">
+            <a:endParaRPr b="0" lang="en-US" sz="900" spc="-1" strike="noStrike">
               <a:latin typeface="Times New Roman"/>
             </a:endParaRPr>
           </a:p>
@@ -4092,8 +4032,8 @@
         </p:nvSpPr>
         <p:spPr>
           <a:xfrm>
-            <a:off x="6469560" y="677520"/>
-            <a:ext cx="133200" cy="360"/>
+            <a:off x="6413040" y="685800"/>
+            <a:ext cx="245520" cy="0"/>
           </a:xfrm>
           <a:prstGeom prst="line">
             <a:avLst/>
@@ -4128,7 +4068,7 @@
         <p:spPr>
           <a:xfrm>
             <a:off x="6658560" y="467280"/>
-            <a:ext cx="420120" cy="420120"/>
+            <a:ext cx="419760" cy="419760"/>
           </a:xfrm>
           <a:prstGeom prst="ellipse">
             <a:avLst/>
@@ -4174,15 +4114,16 @@
               <a:buNone/>
             </a:pPr>
             <a:r>
-              <a:rPr b="1" lang="en-US" sz="800" spc="-1" strike="noStrike">
+              <a:rPr b="1" lang="en-US" sz="900" spc="-1" strike="noStrike">
                 <a:solidFill>
                   <a:srgbClr val="16213a"/>
                 </a:solidFill>
                 <a:latin typeface="Times New Roman"/>
+                <a:ea typeface="DejaVu Sans"/>
               </a:rPr>
               <a:t>x0</a:t>
             </a:r>
-            <a:endParaRPr b="0" lang="en-US" sz="800" spc="-1" strike="noStrike">
+            <a:endParaRPr b="0" lang="en-US" sz="900" spc="-1" strike="noStrike">
               <a:latin typeface="Times New Roman"/>
             </a:endParaRPr>
           </a:p>
@@ -4196,8 +4137,8 @@
         </p:nvSpPr>
         <p:spPr>
           <a:xfrm>
-            <a:off x="4252320" y="1146600"/>
-            <a:ext cx="2882160" cy="312480"/>
+            <a:off x="3886200" y="1146600"/>
+            <a:ext cx="3247920" cy="312120"/>
           </a:xfrm>
           <a:prstGeom prst="roundRect">
             <a:avLst>
@@ -4245,15 +4186,16 @@
               <a:buNone/>
             </a:pPr>
             <a:r>
-              <a:rPr b="1" lang="en-US" sz="800" spc="-1" strike="noStrike">
+              <a:rPr b="1" lang="en-US" sz="900" spc="-1" strike="noStrike">
                 <a:solidFill>
                   <a:srgbClr val="16213a"/>
                 </a:solidFill>
                 <a:latin typeface="Times New Roman"/>
+                <a:ea typeface="DejaVu Sans"/>
               </a:rPr>
               <a:t>differentiable STL robustness ∇ρ (STLCG) steers sampling</a:t>
             </a:r>
-            <a:endParaRPr b="0" lang="en-US" sz="800" spc="-1" strike="noStrike">
+            <a:endParaRPr b="0" lang="en-US" sz="900" spc="-1" strike="noStrike">
               <a:latin typeface="Times New Roman"/>
             </a:endParaRPr>
           </a:p>
@@ -4373,7 +4315,7 @@
         <p:spPr>
           <a:xfrm>
             <a:off x="2833200" y="1641960"/>
-            <a:ext cx="1507320" cy="390600"/>
+            <a:ext cx="1506960" cy="390240"/>
           </a:xfrm>
           <a:prstGeom prst="roundRect">
             <a:avLst>
@@ -4421,15 +4363,16 @@
               <a:buNone/>
             </a:pPr>
             <a:r>
-              <a:rPr b="1" lang="en-US" sz="800" spc="-1" strike="noStrike">
+              <a:rPr b="1" lang="en-US" sz="900" spc="-1" strike="noStrike">
                 <a:solidFill>
                   <a:srgbClr val="16213a"/>
                 </a:solidFill>
                 <a:latin typeface="Times New Roman"/>
+                <a:ea typeface="DejaVu Sans"/>
               </a:rPr>
               <a:t>operator normalization</a:t>
             </a:r>
-            <a:endParaRPr b="0" lang="en-US" sz="800" spc="-1" strike="noStrike">
+            <a:endParaRPr b="0" lang="en-US" sz="900" spc="-1" strike="noStrike">
               <a:latin typeface="Times New Roman"/>
             </a:endParaRPr>
           </a:p>
@@ -4441,24 +4384,26 @@
               <a:buNone/>
             </a:pPr>
             <a:r>
-              <a:rPr b="1" lang="en-US" sz="800" spc="-1" strike="noStrike">
+              <a:rPr b="1" lang="en-US" sz="900" spc="-1" strike="noStrike">
                 <a:solidFill>
                   <a:srgbClr val="16213a"/>
                 </a:solidFill>
                 <a:latin typeface="Times New Roman"/>
+                <a:ea typeface="DejaVu Sans"/>
               </a:rPr>
               <a:t>→</a:t>
             </a:r>
             <a:r>
-              <a:rPr b="1" lang="en-US" sz="800" spc="-1" strike="noStrike">
+              <a:rPr b="1" lang="en-US" sz="900" spc="-1" strike="noStrike">
                 <a:solidFill>
                   <a:srgbClr val="16213a"/>
                 </a:solidFill>
                 <a:latin typeface="Times New Roman"/>
+                <a:ea typeface="DejaVu Sans"/>
               </a:rPr>
               <a:t>,↔ ⇒ basis</a:t>
             </a:r>
-            <a:endParaRPr b="0" lang="en-US" sz="800" spc="-1" strike="noStrike">
+            <a:endParaRPr b="0" lang="en-US" sz="900" spc="-1" strike="noStrike">
               <a:latin typeface="Times New Roman"/>
             </a:endParaRPr>
           </a:p>
@@ -4473,7 +4418,7 @@
         <p:spPr>
           <a:xfrm>
             <a:off x="4452120" y="1641960"/>
-            <a:ext cx="1064160" cy="390600"/>
+            <a:ext cx="1063800" cy="390240"/>
           </a:xfrm>
           <a:prstGeom prst="roundRect">
             <a:avLst>
@@ -4521,15 +4466,16 @@
               <a:buNone/>
             </a:pPr>
             <a:r>
-              <a:rPr b="1" lang="en-US" sz="800" spc="-1" strike="noStrike">
+              <a:rPr b="1" lang="en-US" sz="900" spc="-1" strike="noStrike">
                 <a:solidFill>
                   <a:srgbClr val="16213a"/>
                 </a:solidFill>
                 <a:latin typeface="Times New Roman"/>
+                <a:ea typeface="DejaVu Sans"/>
               </a:rPr>
               <a:t>nested-tree</a:t>
             </a:r>
-            <a:endParaRPr b="0" lang="en-US" sz="800" spc="-1" strike="noStrike">
+            <a:endParaRPr b="0" lang="en-US" sz="900" spc="-1" strike="noStrike">
               <a:latin typeface="Times New Roman"/>
             </a:endParaRPr>
           </a:p>
@@ -4541,15 +4487,16 @@
               <a:buNone/>
             </a:pPr>
             <a:r>
-              <a:rPr b="1" lang="en-US" sz="800" spc="-1" strike="noStrike">
+              <a:rPr b="1" lang="en-US" sz="900" spc="-1" strike="noStrike">
                 <a:solidFill>
                   <a:srgbClr val="16213a"/>
                 </a:solidFill>
                 <a:latin typeface="Times New Roman"/>
+                <a:ea typeface="DejaVu Sans"/>
               </a:rPr>
               <a:t>decomposition</a:t>
             </a:r>
-            <a:endParaRPr b="0" lang="en-US" sz="800" spc="-1" strike="noStrike">
+            <a:endParaRPr b="0" lang="en-US" sz="900" spc="-1" strike="noStrike">
               <a:latin typeface="Times New Roman"/>
             </a:endParaRPr>
           </a:p>
@@ -4564,7 +4511,7 @@
         <p:spPr>
           <a:xfrm>
             <a:off x="5627160" y="1641960"/>
-            <a:ext cx="1507320" cy="390600"/>
+            <a:ext cx="1506960" cy="390240"/>
           </a:xfrm>
           <a:prstGeom prst="roundRect">
             <a:avLst>
@@ -4612,15 +4559,16 @@
               <a:buNone/>
             </a:pPr>
             <a:r>
-              <a:rPr b="1" lang="en-US" sz="800" spc="-1" strike="noStrike">
+              <a:rPr b="1" lang="en-US" sz="900" spc="-1" strike="noStrike">
                 <a:solidFill>
                   <a:srgbClr val="16213a"/>
                 </a:solidFill>
                 <a:latin typeface="Times New Roman"/>
+                <a:ea typeface="DejaVu Sans"/>
               </a:rPr>
               <a:t>feasibility self-check</a:t>
             </a:r>
-            <a:endParaRPr b="0" lang="en-US" sz="800" spc="-1" strike="noStrike">
+            <a:endParaRPr b="0" lang="en-US" sz="900" spc="-1" strike="noStrike">
               <a:latin typeface="Times New Roman"/>
             </a:endParaRPr>
           </a:p>
@@ -4632,24 +4580,26 @@
               <a:buNone/>
             </a:pPr>
             <a:r>
-              <a:rPr b="1" lang="en-US" sz="800" spc="-1" strike="noStrike">
+              <a:rPr b="1" lang="en-US" sz="900" spc="-1" strike="noStrike">
                 <a:solidFill>
                   <a:srgbClr val="16213a"/>
                 </a:solidFill>
                 <a:latin typeface="Times New Roman"/>
+                <a:ea typeface="DejaVu Sans"/>
               </a:rPr>
               <a:t>→ </a:t>
             </a:r>
             <a:r>
-              <a:rPr b="1" lang="en-US" sz="800" spc="-1" strike="noStrike">
+              <a:rPr b="1" lang="en-US" sz="900" spc="-1" strike="noStrike">
                 <a:solidFill>
                   <a:srgbClr val="16213a"/>
                 </a:solidFill>
                 <a:latin typeface="Times New Roman"/>
+                <a:ea typeface="DejaVu Sans"/>
               </a:rPr>
               <a:t>A* if OOD</a:t>
             </a:r>
-            <a:endParaRPr b="0" lang="en-US" sz="800" spc="-1" strike="noStrike">
+            <a:endParaRPr b="0" lang="en-US" sz="900" spc="-1" strike="noStrike">
               <a:latin typeface="Times New Roman"/>
             </a:endParaRPr>
           </a:p>
@@ -4668,7 +4618,7 @@
         <p:spPr>
           <a:xfrm>
             <a:off x="3017520" y="2278440"/>
-            <a:ext cx="3977280" cy="236160"/>
+            <a:ext cx="3976920" cy="235800"/>
           </a:xfrm>
           <a:prstGeom prst="rect">
             <a:avLst/>
@@ -4687,7 +4637,7 @@
         <p:spPr>
           <a:xfrm>
             <a:off x="7360920" y="116640"/>
-            <a:ext cx="4571640" cy="168120"/>
+            <a:ext cx="4571280" cy="167760"/>
           </a:xfrm>
           <a:prstGeom prst="rect">
             <a:avLst/>
@@ -4720,11 +4670,12 @@
                   <a:srgbClr val="16213a"/>
                 </a:solidFill>
                 <a:latin typeface="Times New Roman"/>
+                <a:ea typeface="DejaVu Sans"/>
               </a:rPr>
               <a:t>(c) TeLoGraF plan (no A*)</a:t>
             </a:r>
             <a:endParaRPr b="0" lang="en-US" sz="1100" spc="-1" strike="noStrike">
-              <a:latin typeface="Times New Roman"/>
+              <a:latin typeface="Arial"/>
             </a:endParaRPr>
           </a:p>
         </p:txBody>
@@ -4742,7 +4693,7 @@
         <p:spPr>
           <a:xfrm>
             <a:off x="7379280" y="402480"/>
-            <a:ext cx="2740680" cy="2102760"/>
+            <a:ext cx="2740320" cy="2102400"/>
           </a:xfrm>
           <a:prstGeom prst="rect">
             <a:avLst/>
@@ -4761,7 +4712,7 @@
         <p:spPr>
           <a:xfrm>
             <a:off x="10287000" y="502920"/>
-            <a:ext cx="1874160" cy="487080"/>
+            <a:ext cx="1873800" cy="548280"/>
           </a:xfrm>
           <a:prstGeom prst="rect">
             <a:avLst/>
@@ -4789,16 +4740,17 @@
               <a:buNone/>
             </a:pPr>
             <a:r>
-              <a:rPr b="1" i="1" lang="en-US" sz="800" spc="-1" strike="noStrike">
+              <a:rPr b="1" i="1" lang="en-US" sz="900" spc="-1" strike="noStrike">
                 <a:solidFill>
                   <a:srgbClr val="16213a"/>
                 </a:solidFill>
                 <a:latin typeface="Times New Roman"/>
+                <a:ea typeface="DejaVu Sans"/>
               </a:rPr>
               <a:t>NL: “Reach the goal within</a:t>
             </a:r>
-            <a:endParaRPr b="0" lang="en-US" sz="800" spc="-1" strike="noStrike">
-              <a:latin typeface="Times New Roman"/>
+            <a:endParaRPr b="0" lang="en-US" sz="900" spc="-1" strike="noStrike">
+              <a:latin typeface="Arial"/>
             </a:endParaRPr>
           </a:p>
           <a:p>
@@ -4809,16 +4761,17 @@
               <a:buNone/>
             </a:pPr>
             <a:r>
-              <a:rPr b="1" i="1" lang="en-US" sz="800" spc="-1" strike="noStrike">
+              <a:rPr b="1" i="1" lang="en-US" sz="900" spc="-1" strike="noStrike">
                 <a:solidFill>
                   <a:srgbClr val="16213a"/>
                 </a:solidFill>
                 <a:latin typeface="Times New Roman"/>
+                <a:ea typeface="DejaVu Sans"/>
               </a:rPr>
               <a:t>70 seconds while always</a:t>
             </a:r>
-            <a:endParaRPr b="0" lang="en-US" sz="800" spc="-1" strike="noStrike">
-              <a:latin typeface="Times New Roman"/>
+            <a:endParaRPr b="0" lang="en-US" sz="900" spc="-1" strike="noStrike">
+              <a:latin typeface="Arial"/>
             </a:endParaRPr>
           </a:p>
           <a:p>
@@ -4829,16 +4782,17 @@
               <a:buNone/>
             </a:pPr>
             <a:r>
-              <a:rPr b="1" i="1" lang="en-US" sz="800" spc="-1" strike="noStrike">
+              <a:rPr b="1" i="1" lang="en-US" sz="900" spc="-1" strike="noStrike">
                 <a:solidFill>
                   <a:srgbClr val="16213a"/>
                 </a:solidFill>
                 <a:latin typeface="Times New Roman"/>
+                <a:ea typeface="DejaVu Sans"/>
               </a:rPr>
               <a:t>keeping safe from every</a:t>
             </a:r>
-            <a:endParaRPr b="0" lang="en-US" sz="800" spc="-1" strike="noStrike">
-              <a:latin typeface="Times New Roman"/>
+            <a:endParaRPr b="0" lang="en-US" sz="900" spc="-1" strike="noStrike">
+              <a:latin typeface="Arial"/>
             </a:endParaRPr>
           </a:p>
           <a:p>
@@ -4849,16 +4803,17 @@
               <a:buNone/>
             </a:pPr>
             <a:r>
-              <a:rPr b="1" i="1" lang="en-US" sz="800" spc="-1" strike="noStrike">
+              <a:rPr b="1" i="1" lang="en-US" sz="900" spc="-1" strike="noStrike">
                 <a:solidFill>
                   <a:srgbClr val="16213a"/>
                 </a:solidFill>
                 <a:latin typeface="Times New Roman"/>
+                <a:ea typeface="DejaVu Sans"/>
               </a:rPr>
               <a:t>obstacle.”</a:t>
             </a:r>
-            <a:endParaRPr b="0" lang="en-US" sz="800" spc="-1" strike="noStrike">
-              <a:latin typeface="Times New Roman"/>
+            <a:endParaRPr b="0" lang="en-US" sz="900" spc="-1" strike="noStrike">
+              <a:latin typeface="Arial"/>
             </a:endParaRPr>
           </a:p>
         </p:txBody>
@@ -4876,7 +4831,7 @@
         <p:spPr>
           <a:xfrm>
             <a:off x="10287000" y="1417320"/>
-            <a:ext cx="1782720" cy="192960"/>
+            <a:ext cx="1782360" cy="192600"/>
           </a:xfrm>
           <a:prstGeom prst="rect">
             <a:avLst/>
@@ -4894,8 +4849,8 @@
         </p:nvSpPr>
         <p:spPr>
           <a:xfrm>
-            <a:off x="10287000" y="1831320"/>
-            <a:ext cx="1919880" cy="122400"/>
+            <a:off x="10287000" y="1824120"/>
+            <a:ext cx="1919520" cy="136440"/>
           </a:xfrm>
           <a:prstGeom prst="rect">
             <a:avLst/>
@@ -4923,16 +4878,17 @@
               <a:buNone/>
             </a:pPr>
             <a:r>
-              <a:rPr b="1" lang="en-US" sz="800" spc="-1" strike="noStrike">
+              <a:rPr b="1" lang="en-US" sz="900" spc="-1" strike="noStrike">
                 <a:solidFill>
                   <a:srgbClr val="16213a"/>
                 </a:solidFill>
                 <a:latin typeface="Times New Roman"/>
+                <a:ea typeface="DejaVu Sans"/>
               </a:rPr>
               <a:t>exec 53 s + 4 s plan (in time)</a:t>
             </a:r>
-            <a:endParaRPr b="0" lang="en-US" sz="800" spc="-1" strike="noStrike">
-              <a:latin typeface="Times New Roman"/>
+            <a:endParaRPr b="0" lang="en-US" sz="900" spc="-1" strike="noStrike">
+              <a:latin typeface="Arial"/>
             </a:endParaRPr>
           </a:p>
         </p:txBody>
@@ -4950,7 +4906,7 @@
         <p:spPr>
           <a:xfrm>
             <a:off x="10287000" y="2057400"/>
-            <a:ext cx="1828440" cy="183960"/>
+            <a:ext cx="1828080" cy="183600"/>
           </a:xfrm>
           <a:prstGeom prst="rect">
             <a:avLst/>

</xml_diff>